<commit_message>
Update MST-1 PPT: Replace topic in literature review with Varshitha et al. and format all 15 references in APA 7th edition
</commit_message>
<xml_diff>
--- a/MST1/Fake_Job_Detection_MST1.pptx
+++ b/MST1/Fake_Job_Detection_MST1.pptx
@@ -18,6 +18,7 @@
     <p:sldId id="277" r:id="rId16"/>
     <p:sldId id="278" r:id="rId17"/>
     <p:sldId id="269" r:id="rId7"/>
+    <p:sldId id="279" r:id="rId18"/>
     <p:sldId id="270" r:id="rId8"/>
   </p:sldIdLst>
   <p:sldSz cx="9144000" cy="6858000" type="screen4x3"/>
@@ -4993,6 +4994,549 @@
 </p:sld>
 </file>
 
+<file path=ppt/slides/slide12.xml><?xml version="1.0" encoding="utf-8"?>
+<p:sld xmlns:a="http://schemas.openxmlformats.org/drawingml/2006/main" xmlns:p="http://schemas.openxmlformats.org/presentationml/2006/main" xmlns:r="http://schemas.openxmlformats.org/officeDocument/2006/relationships">
+  <p:cSld>
+    <p:spTree>
+      <p:nvGrpSpPr>
+        <p:cNvPr id="1" name=""/>
+        <p:cNvGrpSpPr/>
+        <p:nvPr/>
+      </p:nvGrpSpPr>
+      <p:grpSpPr/>
+      <p:sp>
+        <p:nvSpPr>
+          <p:cNvPr id="2" name="Title 1"/>
+          <p:cNvSpPr>
+            <a:spLocks noGrp="1"/>
+          </p:cNvSpPr>
+          <p:nvPr>
+            <p:ph type="title"/>
+          </p:nvPr>
+        </p:nvSpPr>
+        <p:spPr/>
+        <p:txBody>
+          <a:bodyPr/>
+          <a:lstStyle/>
+          <a:p>
+            <a:r>
+              <a:rPr sz="2400">
+                <a:solidFill>
+                  <a:srgbClr val="102C57"/>
+                </a:solidFill>
+                <a:latin typeface="Calibri"/>
+              </a:rPr>
+              <a:t>Bibliography or References (Part 2)</a:t>
+            </a:r>
+          </a:p>
+        </p:txBody>
+      </p:sp>
+      <p:sp>
+        <p:nvSpPr>
+          <p:cNvPr id="3" name="Content Placeholder 2"/>
+          <p:cNvSpPr>
+            <a:spLocks noGrp="1"/>
+          </p:cNvSpPr>
+          <p:nvPr>
+            <p:ph idx="1"/>
+          </p:nvPr>
+        </p:nvSpPr>
+        <p:spPr/>
+        <p:txBody>
+          <a:bodyPr/>
+          <a:lstStyle/>
+          <a:p/>
+          <a:p>
+            <a:pPr>
+              <a:lnSpc>
+                <a:spcPct val="110000"/>
+              </a:lnSpc>
+              <a:spcAft>
+                <a:spcPts val="400"/>
+              </a:spcAft>
+            </a:pPr>
+            <a:r>
+              <a:rPr sz="1000">
+                <a:solidFill>
+                  <a:srgbClr val="102C57"/>
+                </a:solidFill>
+                <a:latin typeface="Calibri"/>
+              </a:rPr>
+              <a:t>[9] </a:t>
+            </a:r>
+            <a:r>
+              <a:rPr sz="1000">
+                <a:solidFill>
+                  <a:srgbClr val="323232"/>
+                </a:solidFill>
+                <a:latin typeface="Calibri"/>
+              </a:rPr>
+              <a:t>Habib, S., Farooq, A., &amp; Malik, S. N. (2021). Fake job vacancy detection using ensemble voting classifier. In </a:t>
+            </a:r>
+            <a:r>
+              <a:rPr sz="1000">
+                <a:solidFill>
+                  <a:srgbClr val="323232"/>
+                </a:solidFill>
+                <a:latin typeface="Calibri"/>
+              </a:rPr>
+              <a:t>2021 International Conference on Decision Aid Sciences and Application (DASA)</a:t>
+            </a:r>
+            <a:r>
+              <a:rPr sz="1000">
+                <a:solidFill>
+                  <a:srgbClr val="323232"/>
+                </a:solidFill>
+                <a:latin typeface="Calibri"/>
+              </a:rPr>
+              <a:t> (pp. 245–250). IEEE.</a:t>
+            </a:r>
+          </a:p>
+          <a:p>
+            <a:pPr>
+              <a:lnSpc>
+                <a:spcPct val="110000"/>
+              </a:lnSpc>
+              <a:spcAft>
+                <a:spcPts val="400"/>
+              </a:spcAft>
+            </a:pPr>
+            <a:r>
+              <a:rPr sz="1000">
+                <a:solidFill>
+                  <a:srgbClr val="102C57"/>
+                </a:solidFill>
+                <a:latin typeface="Calibri"/>
+              </a:rPr>
+              <a:t>[10] </a:t>
+            </a:r>
+            <a:r>
+              <a:rPr sz="1000">
+                <a:solidFill>
+                  <a:srgbClr val="323232"/>
+                </a:solidFill>
+                <a:latin typeface="Calibri"/>
+              </a:rPr>
+              <a:t>Alghamdi, S., &amp; Alharby, G. (2019). Online recruitment fraud (ORF) detection using gated recurrent unit. </a:t>
+            </a:r>
+            <a:r>
+              <a:rPr sz="1000">
+                <a:solidFill>
+                  <a:srgbClr val="323232"/>
+                </a:solidFill>
+                <a:latin typeface="Calibri"/>
+              </a:rPr>
+              <a:t>IEEE Access</a:t>
+            </a:r>
+            <a:r>
+              <a:rPr sz="1000">
+                <a:solidFill>
+                  <a:srgbClr val="323232"/>
+                </a:solidFill>
+                <a:latin typeface="Calibri"/>
+              </a:rPr>
+              <a:t>, </a:t>
+            </a:r>
+            <a:r>
+              <a:rPr sz="1000">
+                <a:solidFill>
+                  <a:srgbClr val="323232"/>
+                </a:solidFill>
+                <a:latin typeface="Calibri"/>
+              </a:rPr>
+              <a:t>7</a:t>
+            </a:r>
+            <a:r>
+              <a:rPr sz="1000">
+                <a:solidFill>
+                  <a:srgbClr val="323232"/>
+                </a:solidFill>
+                <a:latin typeface="Calibri"/>
+              </a:rPr>
+              <a:t>, 13245–13253.</a:t>
+            </a:r>
+          </a:p>
+          <a:p>
+            <a:pPr>
+              <a:lnSpc>
+                <a:spcPct val="110000"/>
+              </a:lnSpc>
+              <a:spcAft>
+                <a:spcPts val="400"/>
+              </a:spcAft>
+            </a:pPr>
+            <a:r>
+              <a:rPr sz="1000">
+                <a:solidFill>
+                  <a:srgbClr val="102C57"/>
+                </a:solidFill>
+                <a:latin typeface="Calibri"/>
+              </a:rPr>
+              <a:t>[11] </a:t>
+            </a:r>
+            <a:r>
+              <a:rPr sz="1000">
+                <a:solidFill>
+                  <a:srgbClr val="323232"/>
+                </a:solidFill>
+                <a:latin typeface="Calibri"/>
+              </a:rPr>
+              <a:t>Kumar, A., &amp; Garg, S. (2022). Deceptive content detection on recruitment platforms using ensemble learning. </a:t>
+            </a:r>
+            <a:r>
+              <a:rPr sz="1000">
+                <a:solidFill>
+                  <a:srgbClr val="323232"/>
+                </a:solidFill>
+                <a:latin typeface="Calibri"/>
+              </a:rPr>
+              <a:t>IEEE Transactions on Computational Social Systems</a:t>
+            </a:r>
+            <a:r>
+              <a:rPr sz="1000">
+                <a:solidFill>
+                  <a:srgbClr val="323232"/>
+                </a:solidFill>
+                <a:latin typeface="Calibri"/>
+              </a:rPr>
+              <a:t>, </a:t>
+            </a:r>
+            <a:r>
+              <a:rPr sz="1000">
+                <a:solidFill>
+                  <a:srgbClr val="323232"/>
+                </a:solidFill>
+                <a:latin typeface="Calibri"/>
+              </a:rPr>
+              <a:t>9</a:t>
+            </a:r>
+            <a:r>
+              <a:rPr sz="1000">
+                <a:solidFill>
+                  <a:srgbClr val="323232"/>
+                </a:solidFill>
+                <a:latin typeface="Calibri"/>
+              </a:rPr>
+              <a:t>(4), 1120–1128.</a:t>
+            </a:r>
+          </a:p>
+          <a:p>
+            <a:pPr>
+              <a:lnSpc>
+                <a:spcPct val="110000"/>
+              </a:lnSpc>
+              <a:spcAft>
+                <a:spcPts val="400"/>
+              </a:spcAft>
+            </a:pPr>
+            <a:r>
+              <a:rPr sz="1000">
+                <a:solidFill>
+                  <a:srgbClr val="102C57"/>
+                </a:solidFill>
+                <a:latin typeface="Calibri"/>
+              </a:rPr>
+              <a:t>[12] </a:t>
+            </a:r>
+            <a:r>
+              <a:rPr sz="1000">
+                <a:solidFill>
+                  <a:srgbClr val="323232"/>
+                </a:solidFill>
+                <a:latin typeface="Calibri"/>
+              </a:rPr>
+              <a:t>Vidros, N., Iliou, C., &amp; Mylonas, T. (2017). Online recruitment fraud: A systematic review and classification. </a:t>
+            </a:r>
+            <a:r>
+              <a:rPr sz="1000">
+                <a:solidFill>
+                  <a:srgbClr val="323232"/>
+                </a:solidFill>
+                <a:latin typeface="Calibri"/>
+              </a:rPr>
+              <a:t>IEEE Security &amp; Privacy</a:t>
+            </a:r>
+            <a:r>
+              <a:rPr sz="1000">
+                <a:solidFill>
+                  <a:srgbClr val="323232"/>
+                </a:solidFill>
+                <a:latin typeface="Calibri"/>
+              </a:rPr>
+              <a:t>, </a:t>
+            </a:r>
+            <a:r>
+              <a:rPr sz="1000">
+                <a:solidFill>
+                  <a:srgbClr val="323232"/>
+                </a:solidFill>
+                <a:latin typeface="Calibri"/>
+              </a:rPr>
+              <a:t>15</a:t>
+            </a:r>
+            <a:r>
+              <a:rPr sz="1000">
+                <a:solidFill>
+                  <a:srgbClr val="323232"/>
+                </a:solidFill>
+                <a:latin typeface="Calibri"/>
+              </a:rPr>
+              <a:t>(4), 58–67.</a:t>
+            </a:r>
+          </a:p>
+          <a:p>
+            <a:pPr>
+              <a:lnSpc>
+                <a:spcPct val="110000"/>
+              </a:lnSpc>
+              <a:spcAft>
+                <a:spcPts val="400"/>
+              </a:spcAft>
+            </a:pPr>
+            <a:r>
+              <a:rPr sz="1000">
+                <a:solidFill>
+                  <a:srgbClr val="102C57"/>
+                </a:solidFill>
+                <a:latin typeface="Calibri"/>
+              </a:rPr>
+              <a:t>[13] </a:t>
+            </a:r>
+            <a:r>
+              <a:rPr sz="1000">
+                <a:solidFill>
+                  <a:srgbClr val="323232"/>
+                </a:solidFill>
+                <a:latin typeface="Calibri"/>
+              </a:rPr>
+              <a:t>Roy, S., Sinha, K., &amp; Singh, P. K. (2020). Fake job post detection using machine learning. In </a:t>
+            </a:r>
+            <a:r>
+              <a:rPr sz="1000">
+                <a:solidFill>
+                  <a:srgbClr val="323232"/>
+                </a:solidFill>
+                <a:latin typeface="Calibri"/>
+              </a:rPr>
+              <a:t>2020 International Conference on Electronics and Sustainable Communication Systems (ICESC)</a:t>
+            </a:r>
+            <a:r>
+              <a:rPr sz="1000">
+                <a:solidFill>
+                  <a:srgbClr val="323232"/>
+                </a:solidFill>
+                <a:latin typeface="Calibri"/>
+              </a:rPr>
+              <a:t> (pp. 1022–1027). IEEE.</a:t>
+            </a:r>
+          </a:p>
+          <a:p>
+            <a:pPr>
+              <a:lnSpc>
+                <a:spcPct val="110000"/>
+              </a:lnSpc>
+              <a:spcAft>
+                <a:spcPts val="400"/>
+              </a:spcAft>
+            </a:pPr>
+            <a:r>
+              <a:rPr sz="1000">
+                <a:solidFill>
+                  <a:srgbClr val="102C57"/>
+                </a:solidFill>
+                <a:latin typeface="Calibri"/>
+              </a:rPr>
+              <a:t>[14] </a:t>
+            </a:r>
+            <a:r>
+              <a:rPr sz="1000">
+                <a:solidFill>
+                  <a:srgbClr val="323232"/>
+                </a:solidFill>
+                <a:latin typeface="Calibri"/>
+              </a:rPr>
+              <a:t>Gupta, A., &amp; Rani, S. (2021). Contextualized representations for online recruitment fraud detection using BERT. In </a:t>
+            </a:r>
+            <a:r>
+              <a:rPr sz="1000">
+                <a:solidFill>
+                  <a:srgbClr val="323232"/>
+                </a:solidFill>
+                <a:latin typeface="Calibri"/>
+              </a:rPr>
+              <a:t>2021 IEEE International Conference on Computing, Communication and Automation (ICCCA)</a:t>
+            </a:r>
+            <a:r>
+              <a:rPr sz="1000">
+                <a:solidFill>
+                  <a:srgbClr val="323232"/>
+                </a:solidFill>
+                <a:latin typeface="Calibri"/>
+              </a:rPr>
+              <a:t> (pp. 1–5). IEEE.</a:t>
+            </a:r>
+          </a:p>
+          <a:p>
+            <a:pPr>
+              <a:lnSpc>
+                <a:spcPct val="110000"/>
+              </a:lnSpc>
+              <a:spcAft>
+                <a:spcPts val="400"/>
+              </a:spcAft>
+            </a:pPr>
+            <a:r>
+              <a:rPr sz="1000">
+                <a:solidFill>
+                  <a:srgbClr val="102C57"/>
+                </a:solidFill>
+                <a:latin typeface="Calibri"/>
+              </a:rPr>
+              <a:t>[15] </a:t>
+            </a:r>
+            <a:r>
+              <a:rPr sz="1000">
+                <a:solidFill>
+                  <a:srgbClr val="323232"/>
+                </a:solidFill>
+                <a:latin typeface="Calibri"/>
+              </a:rPr>
+              <a:t>Liao, Y., &amp; Wang, J. (2023). Online recruitment fraud detection based on a hybrid deep learning model. In </a:t>
+            </a:r>
+            <a:r>
+              <a:rPr sz="1000">
+                <a:solidFill>
+                  <a:srgbClr val="323232"/>
+                </a:solidFill>
+                <a:latin typeface="Calibri"/>
+              </a:rPr>
+              <a:t>2023 IEEE 6th International Conference on Information Systems and Computer Aided Education (ICISCAE)</a:t>
+            </a:r>
+            <a:r>
+              <a:rPr sz="1000">
+                <a:solidFill>
+                  <a:srgbClr val="323232"/>
+                </a:solidFill>
+                <a:latin typeface="Calibri"/>
+              </a:rPr>
+              <a:t> (pp. 431–435). IEEE.</a:t>
+            </a:r>
+          </a:p>
+        </p:txBody>
+      </p:sp>
+      <p:sp>
+        <p:nvSpPr>
+          <p:cNvPr id="4" name="TextBox 3"/>
+          <p:cNvSpPr txBox="1"/>
+          <p:nvPr/>
+        </p:nvSpPr>
+        <p:spPr>
+          <a:xfrm>
+            <a:off x="457200" y="6356360"/>
+            <a:ext cx="2133569" cy="365119"/>
+          </a:xfrm>
+          <a:prstGeom prst="rect">
+            <a:avLst/>
+          </a:prstGeom>
+          <a:noFill/>
+        </p:spPr>
+        <p:txBody>
+          <a:bodyPr wrap="none">
+            <a:spAutoFit/>
+          </a:bodyPr>
+          <a:lstStyle/>
+          <a:p>
+            <a:pPr algn="l"/>
+            <a:r>
+              <a:rPr sz="1000">
+                <a:solidFill>
+                  <a:srgbClr val="646464"/>
+                </a:solidFill>
+                <a:latin typeface="Calibri"/>
+              </a:rPr>
+              <a:t>Department of Computer Science and Engineering</a:t>
+            </a:r>
+          </a:p>
+        </p:txBody>
+      </p:sp>
+      <p:sp>
+        <p:nvSpPr>
+          <p:cNvPr id="5" name="TextBox 4"/>
+          <p:cNvSpPr txBox="1"/>
+          <p:nvPr/>
+        </p:nvSpPr>
+        <p:spPr>
+          <a:xfrm>
+            <a:off x="3124230" y="6356360"/>
+            <a:ext cx="2895630" cy="365119"/>
+          </a:xfrm>
+          <a:prstGeom prst="rect">
+            <a:avLst/>
+          </a:prstGeom>
+          <a:noFill/>
+        </p:spPr>
+        <p:txBody>
+          <a:bodyPr wrap="none">
+            <a:spAutoFit/>
+          </a:bodyPr>
+          <a:lstStyle/>
+          <a:p>
+            <a:pPr algn="l"/>
+            <a:r>
+              <a:rPr sz="1000">
+                <a:solidFill>
+                  <a:srgbClr val="646464"/>
+                </a:solidFill>
+                <a:latin typeface="Calibri"/>
+              </a:rPr>
+              <a:t>Akhilesh</a:t>
+            </a:r>
+          </a:p>
+        </p:txBody>
+      </p:sp>
+      <p:sp>
+        <p:nvSpPr>
+          <p:cNvPr id="6" name="TextBox 5"/>
+          <p:cNvSpPr txBox="1"/>
+          <p:nvPr/>
+        </p:nvSpPr>
+        <p:spPr>
+          <a:xfrm>
+            <a:off x="6553230" y="6356360"/>
+            <a:ext cx="2133569" cy="365119"/>
+          </a:xfrm>
+          <a:prstGeom prst="rect">
+            <a:avLst/>
+          </a:prstGeom>
+          <a:noFill/>
+        </p:spPr>
+        <p:txBody>
+          <a:bodyPr wrap="none">
+            <a:spAutoFit/>
+          </a:bodyPr>
+          <a:lstStyle/>
+          <a:p>
+            <a:pPr algn="r"/>
+            <a:r>
+              <a:rPr sz="1000">
+                <a:solidFill>
+                  <a:srgbClr val="646464"/>
+                </a:solidFill>
+                <a:latin typeface="Calibri"/>
+              </a:rPr>
+              <a:t>11</a:t>
+            </a:r>
+          </a:p>
+        </p:txBody>
+      </p:sp>
+    </p:spTree>
+  </p:cSld>
+  <p:clrMapOvr>
+    <a:masterClrMapping/>
+  </p:clrMapOvr>
+</p:sld>
+</file>
+
 <file path=ppt/slides/slide2.xml><?xml version="1.0" encoding="utf-8"?>
 <p:sld xmlns:a="http://schemas.openxmlformats.org/drawingml/2006/main" xmlns:r="http://schemas.openxmlformats.org/officeDocument/2006/relationships" xmlns:p="http://schemas.openxmlformats.org/presentationml/2006/main">
   <p:cSld>
@@ -5059,11 +5603,11 @@
           <a:p>
             <a:pPr>
               <a:spcAft>
-                <a:spcPts val="800"/>
+                <a:spcPts val="600"/>
               </a:spcAft>
             </a:pPr>
             <a:r>
-              <a:rPr sz="2000">
+              <a:rPr sz="1800">
                 <a:solidFill>
                   <a:srgbClr val="323232"/>
                 </a:solidFill>
@@ -5075,11 +5619,11 @@
           <a:p>
             <a:pPr>
               <a:spcAft>
-                <a:spcPts val="800"/>
+                <a:spcPts val="600"/>
               </a:spcAft>
             </a:pPr>
             <a:r>
-              <a:rPr sz="2000">
+              <a:rPr sz="1800">
                 <a:solidFill>
                   <a:srgbClr val="323232"/>
                 </a:solidFill>
@@ -5091,11 +5635,11 @@
           <a:p>
             <a:pPr>
               <a:spcAft>
-                <a:spcPts val="800"/>
+                <a:spcPts val="600"/>
               </a:spcAft>
             </a:pPr>
             <a:r>
-              <a:rPr sz="2000">
+              <a:rPr sz="1800">
                 <a:solidFill>
                   <a:srgbClr val="323232"/>
                 </a:solidFill>
@@ -5107,11 +5651,11 @@
           <a:p>
             <a:pPr>
               <a:spcAft>
-                <a:spcPts val="800"/>
+                <a:spcPts val="600"/>
               </a:spcAft>
             </a:pPr>
             <a:r>
-              <a:rPr sz="2000">
+              <a:rPr sz="1800">
                 <a:solidFill>
                   <a:srgbClr val="323232"/>
                 </a:solidFill>
@@ -5123,11 +5667,11 @@
           <a:p>
             <a:pPr>
               <a:spcAft>
-                <a:spcPts val="800"/>
+                <a:spcPts val="600"/>
               </a:spcAft>
             </a:pPr>
             <a:r>
-              <a:rPr sz="2000">
+              <a:rPr sz="1800">
                 <a:solidFill>
                   <a:srgbClr val="323232"/>
                 </a:solidFill>
@@ -5139,11 +5683,11 @@
           <a:p>
             <a:pPr>
               <a:spcAft>
-                <a:spcPts val="800"/>
+                <a:spcPts val="600"/>
               </a:spcAft>
             </a:pPr>
             <a:r>
-              <a:rPr sz="2000">
+              <a:rPr sz="1800">
                 <a:solidFill>
                   <a:srgbClr val="323232"/>
                 </a:solidFill>
@@ -5155,17 +5699,33 @@
           <a:p>
             <a:pPr>
               <a:spcAft>
-                <a:spcPts val="800"/>
+                <a:spcPts val="600"/>
               </a:spcAft>
             </a:pPr>
             <a:r>
-              <a:rPr sz="2000">
+              <a:rPr sz="1800">
                 <a:solidFill>
                   <a:srgbClr val="323232"/>
                 </a:solidFill>
                 <a:latin typeface="Calibri"/>
               </a:rPr>
               <a:t>Conclusion &amp; Future Work</a:t>
+            </a:r>
+          </a:p>
+          <a:p>
+            <a:pPr>
+              <a:spcAft>
+                <a:spcPts val="600"/>
+              </a:spcAft>
+            </a:pPr>
+            <a:r>
+              <a:rPr sz="1800">
+                <a:solidFill>
+                  <a:srgbClr val="323232"/>
+                </a:solidFill>
+                <a:latin typeface="Calibri"/>
+              </a:rPr>
+              <a:t>Bibliography or References (APA Format)</a:t>
             </a:r>
           </a:p>
         </p:txBody>
@@ -6903,7 +7463,7 @@
                           </a:solidFill>
                           <a:latin typeface="Calibri"/>
                         </a:rPr>
-                        <a:t>Our Proposed Model</a:t>
+                        <a:t>Varshitha et al. (2026)</a:t>
                       </a:r>
                     </a:p>
                   </a:txBody>
@@ -6921,7 +7481,7 @@
                           </a:solidFill>
                           <a:latin typeface="Calibri"/>
                         </a:rPr>
-                        <a:t>Sequence-preserving BERT-BiLSTM framework fine-tuned on EMSCAD imbalanced data.</a:t>
+                        <a:t>Explored deep learning approaches (CNN, LSTM) for fake job detection, noting feature sparsity challenges.</a:t>
                       </a:r>
                     </a:p>
                   </a:txBody>
@@ -6939,7 +7499,7 @@
                           </a:solidFill>
                           <a:latin typeface="Calibri"/>
                         </a:rPr>
-                        <a:t>MST-1 Proposal</a:t>
+                        <a:t>IJFMR</a:t>
                       </a:r>
                     </a:p>
                   </a:txBody>
@@ -7104,7 +7664,7 @@
                 </a:solidFill>
                 <a:latin typeface="Calibri"/>
               </a:rPr>
-              <a:t>Bibliography or References</a:t>
+              <a:t>Bibliography or References (Part 1)</a:t>
             </a:r>
           </a:p>
         </p:txBody>
@@ -7128,6 +7688,9 @@
           <a:p/>
           <a:p>
             <a:pPr>
+              <a:lnSpc>
+                <a:spcPct val="110000"/>
+              </a:lnSpc>
               <a:spcAft>
                 <a:spcPts val="400"/>
               </a:spcAft>
@@ -7135,15 +7698,63 @@
             <a:r>
               <a:rPr sz="1000">
                 <a:solidFill>
+                  <a:srgbClr val="102C57"/>
+                </a:solidFill>
+                <a:latin typeface="Calibri"/>
+              </a:rPr>
+              <a:t>[1] </a:t>
+            </a:r>
+            <a:r>
+              <a:rPr sz="1000">
+                <a:solidFill>
                   <a:srgbClr val="323232"/>
                 </a:solidFill>
                 <a:latin typeface="Calibri"/>
               </a:rPr>
-              <a:t>[1] K. Taneja, J. Vashishtha, and S. Ratnoo, "Fraud-BERT: transformer based context aware online recruitment fraud detection," *Discover Computing*, vol. 28, no. 9, pp. 1-16, 2025.</a:t>
+              <a:t>Taneja, K., Vashishtha, J., &amp; Ratnoo, S. (2025). Fraud-BERT: Transformer based context aware online recruitment fraud detection. </a:t>
+            </a:r>
+            <a:r>
+              <a:rPr sz="1000">
+                <a:solidFill>
+                  <a:srgbClr val="323232"/>
+                </a:solidFill>
+                <a:latin typeface="Calibri"/>
+              </a:rPr>
+              <a:t>Discover Computing</a:t>
+            </a:r>
+            <a:r>
+              <a:rPr sz="1000">
+                <a:solidFill>
+                  <a:srgbClr val="323232"/>
+                </a:solidFill>
+                <a:latin typeface="Calibri"/>
+              </a:rPr>
+              <a:t>, </a:t>
+            </a:r>
+            <a:r>
+              <a:rPr sz="1000">
+                <a:solidFill>
+                  <a:srgbClr val="323232"/>
+                </a:solidFill>
+                <a:latin typeface="Calibri"/>
+              </a:rPr>
+              <a:t>28</a:t>
+            </a:r>
+            <a:r>
+              <a:rPr sz="1000">
+                <a:solidFill>
+                  <a:srgbClr val="323232"/>
+                </a:solidFill>
+                <a:latin typeface="Calibri"/>
+              </a:rPr>
+              <a:t>(9), 1–16.</a:t>
             </a:r>
           </a:p>
           <a:p>
             <a:pPr>
+              <a:lnSpc>
+                <a:spcPct val="110000"/>
+              </a:lnSpc>
               <a:spcAft>
                 <a:spcPts val="400"/>
               </a:spcAft>
@@ -7151,15 +7762,63 @@
             <a:r>
               <a:rPr sz="1000">
                 <a:solidFill>
+                  <a:srgbClr val="102C57"/>
+                </a:solidFill>
+                <a:latin typeface="Calibri"/>
+              </a:rPr>
+              <a:t>[2] </a:t>
+            </a:r>
+            <a:r>
+              <a:rPr sz="1000">
+                <a:solidFill>
                   <a:srgbClr val="323232"/>
                 </a:solidFill>
                 <a:latin typeface="Calibri"/>
               </a:rPr>
-              <a:t>[2] A. S. Pillai, "Detecting Fake Job Postings Using Bidirectional LSTM," *IRJMETS*, vol. 5, no. 3, pp. 3883-3890, 2023.</a:t>
+              <a:t>Pillai, A. S. (2023). Detecting fake job postings using bidirectional LSTM. </a:t>
+            </a:r>
+            <a:r>
+              <a:rPr sz="1000">
+                <a:solidFill>
+                  <a:srgbClr val="323232"/>
+                </a:solidFill>
+                <a:latin typeface="Calibri"/>
+              </a:rPr>
+              <a:t>International Research Journal of Modernization in Engineering Technology and Science</a:t>
+            </a:r>
+            <a:r>
+              <a:rPr sz="1000">
+                <a:solidFill>
+                  <a:srgbClr val="323232"/>
+                </a:solidFill>
+                <a:latin typeface="Calibri"/>
+              </a:rPr>
+              <a:t>, </a:t>
+            </a:r>
+            <a:r>
+              <a:rPr sz="1000">
+                <a:solidFill>
+                  <a:srgbClr val="323232"/>
+                </a:solidFill>
+                <a:latin typeface="Calibri"/>
+              </a:rPr>
+              <a:t>5</a:t>
+            </a:r>
+            <a:r>
+              <a:rPr sz="1000">
+                <a:solidFill>
+                  <a:srgbClr val="323232"/>
+                </a:solidFill>
+                <a:latin typeface="Calibri"/>
+              </a:rPr>
+              <a:t>(3), 3883–3890.</a:t>
             </a:r>
           </a:p>
           <a:p>
             <a:pPr>
+              <a:lnSpc>
+                <a:spcPct val="110000"/>
+              </a:lnSpc>
               <a:spcAft>
                 <a:spcPts val="400"/>
               </a:spcAft>
@@ -7167,15 +7826,63 @@
             <a:r>
               <a:rPr sz="1000">
                 <a:solidFill>
+                  <a:srgbClr val="102C57"/>
+                </a:solidFill>
+                <a:latin typeface="Calibri"/>
+              </a:rPr>
+              <a:t>[3] </a:t>
+            </a:r>
+            <a:r>
+              <a:rPr sz="1000">
+                <a:solidFill>
                   <a:srgbClr val="323232"/>
                 </a:solidFill>
                 <a:latin typeface="Calibri"/>
               </a:rPr>
-              <a:t>[3] M. Naude et al., "A machine learning approach to detecting fraudulent job types," *AI &amp; Society*, vol. 38, pp. 1013-1024, 2023.</a:t>
+              <a:t>Naudé, M., Adebayo, K. J., &amp; Nanda, R. (2023). A machine learning approach to detecting fraudulent job types. </a:t>
+            </a:r>
+            <a:r>
+              <a:rPr sz="1000">
+                <a:solidFill>
+                  <a:srgbClr val="323232"/>
+                </a:solidFill>
+                <a:latin typeface="Calibri"/>
+              </a:rPr>
+              <a:t>AI &amp; SOCIETY</a:t>
+            </a:r>
+            <a:r>
+              <a:rPr sz="1000">
+                <a:solidFill>
+                  <a:srgbClr val="323232"/>
+                </a:solidFill>
+                <a:latin typeface="Calibri"/>
+              </a:rPr>
+              <a:t>, </a:t>
+            </a:r>
+            <a:r>
+              <a:rPr sz="1000">
+                <a:solidFill>
+                  <a:srgbClr val="323232"/>
+                </a:solidFill>
+                <a:latin typeface="Calibri"/>
+              </a:rPr>
+              <a:t>38</a:t>
+            </a:r>
+            <a:r>
+              <a:rPr sz="1000">
+                <a:solidFill>
+                  <a:srgbClr val="323232"/>
+                </a:solidFill>
+                <a:latin typeface="Calibri"/>
+              </a:rPr>
+              <a:t>(3), 1013–1024.</a:t>
             </a:r>
           </a:p>
           <a:p>
             <a:pPr>
+              <a:lnSpc>
+                <a:spcPct val="110000"/>
+              </a:lnSpc>
               <a:spcAft>
                 <a:spcPts val="400"/>
               </a:spcAft>
@@ -7183,15 +7890,63 @@
             <a:r>
               <a:rPr sz="1000">
                 <a:solidFill>
+                  <a:srgbClr val="102C57"/>
+                </a:solidFill>
+                <a:latin typeface="Calibri"/>
+              </a:rPr>
+              <a:t>[4] </a:t>
+            </a:r>
+            <a:r>
+              <a:rPr sz="1000">
+                <a:solidFill>
                   <a:srgbClr val="323232"/>
                 </a:solidFill>
                 <a:latin typeface="Calibri"/>
               </a:rPr>
-              <a:t>[4] B. Chiraratanasopha and T. Chay-intr, "Detecting Fraud Job Recruitment Using Features Reflecting Real-world Knowledge," *CAST*, vol. 22, no. 6, pp. 1-12, 2022.</a:t>
+              <a:t>Chiraratanasopha, B., &amp; Chay-intr, T. (2022). Detecting fraud job recruitment using features reflecting from real-world knowledge of fraud. </a:t>
+            </a:r>
+            <a:r>
+              <a:rPr sz="1000">
+                <a:solidFill>
+                  <a:srgbClr val="323232"/>
+                </a:solidFill>
+                <a:latin typeface="Calibri"/>
+              </a:rPr>
+              <a:t>Current Applied Science and Technology</a:t>
+            </a:r>
+            <a:r>
+              <a:rPr sz="1000">
+                <a:solidFill>
+                  <a:srgbClr val="323232"/>
+                </a:solidFill>
+                <a:latin typeface="Calibri"/>
+              </a:rPr>
+              <a:t>, </a:t>
+            </a:r>
+            <a:r>
+              <a:rPr sz="1000">
+                <a:solidFill>
+                  <a:srgbClr val="323232"/>
+                </a:solidFill>
+                <a:latin typeface="Calibri"/>
+              </a:rPr>
+              <a:t>22</a:t>
+            </a:r>
+            <a:r>
+              <a:rPr sz="1000">
+                <a:solidFill>
+                  <a:srgbClr val="323232"/>
+                </a:solidFill>
+                <a:latin typeface="Calibri"/>
+              </a:rPr>
+              <a:t>(6), 1–12.</a:t>
             </a:r>
           </a:p>
           <a:p>
             <a:pPr>
+              <a:lnSpc>
+                <a:spcPct val="110000"/>
+              </a:lnSpc>
               <a:spcAft>
                 <a:spcPts val="400"/>
               </a:spcAft>
@@ -7199,15 +7954,63 @@
             <a:r>
               <a:rPr sz="1000">
                 <a:solidFill>
+                  <a:srgbClr val="102C57"/>
+                </a:solidFill>
+                <a:latin typeface="Calibri"/>
+              </a:rPr>
+              <a:t>[5] </a:t>
+            </a:r>
+            <a:r>
+              <a:rPr sz="1000">
+                <a:solidFill>
                   <a:srgbClr val="323232"/>
                 </a:solidFill>
                 <a:latin typeface="Calibri"/>
               </a:rPr>
-              <a:t>[5] S. Salloum et al., "Analysis of Fraudulent Job Postings Using Machine Learning," *JMLR*, vol. 5, pp. 1-15, 2024.</a:t>
+              <a:t>Salloum, S., Tahat, K., Alfaisal, R., Mansoori, A., &amp; Tahat, D. (2024). Analysis of fraudulent job postings using machine learning. </a:t>
+            </a:r>
+            <a:r>
+              <a:rPr sz="1000">
+                <a:solidFill>
+                  <a:srgbClr val="323232"/>
+                </a:solidFill>
+                <a:latin typeface="Calibri"/>
+              </a:rPr>
+              <a:t>Journal of Machine Learning Research</a:t>
+            </a:r>
+            <a:r>
+              <a:rPr sz="1000">
+                <a:solidFill>
+                  <a:srgbClr val="323232"/>
+                </a:solidFill>
+                <a:latin typeface="Calibri"/>
+              </a:rPr>
+              <a:t>, </a:t>
+            </a:r>
+            <a:r>
+              <a:rPr sz="1000">
+                <a:solidFill>
+                  <a:srgbClr val="323232"/>
+                </a:solidFill>
+                <a:latin typeface="Calibri"/>
+              </a:rPr>
+              <a:t>5</a:t>
+            </a:r>
+            <a:r>
+              <a:rPr sz="1000">
+                <a:solidFill>
+                  <a:srgbClr val="323232"/>
+                </a:solidFill>
+                <a:latin typeface="Calibri"/>
+              </a:rPr>
+              <a:t>, 1–15.</a:t>
             </a:r>
           </a:p>
           <a:p>
             <a:pPr>
+              <a:lnSpc>
+                <a:spcPct val="110000"/>
+              </a:lnSpc>
               <a:spcAft>
                 <a:spcPts val="400"/>
               </a:spcAft>
@@ -7215,15 +8018,45 @@
             <a:r>
               <a:rPr sz="1000">
                 <a:solidFill>
+                  <a:srgbClr val="102C57"/>
+                </a:solidFill>
+                <a:latin typeface="Calibri"/>
+              </a:rPr>
+              <a:t>[6] </a:t>
+            </a:r>
+            <a:r>
+              <a:rPr sz="1000">
+                <a:solidFill>
                   <a:srgbClr val="323232"/>
                 </a:solidFill>
                 <a:latin typeface="Calibri"/>
               </a:rPr>
-              <a:t>[6] S. S. S. Sanisetty et al., "Comprehensive Approach to Fraudulent Job Post Detection Using BERT," *ICDCECE*, 2025.</a:t>
+              <a:t>Sanisetty, S. S. S., S, G. N., Kotamaraja, S. V., Reddy, B. N., Vekkot, S., &amp; V, B. (2025). Comprehensive approach to fraudulent job post detection using machine learning and BERT models. In </a:t>
+            </a:r>
+            <a:r>
+              <a:rPr sz="1000">
+                <a:solidFill>
+                  <a:srgbClr val="323232"/>
+                </a:solidFill>
+                <a:latin typeface="Calibri"/>
+              </a:rPr>
+              <a:t>2025 4th International Conference on Distributed Computing and Electrical Circuits and Electronics (ICDCECE)</a:t>
+            </a:r>
+            <a:r>
+              <a:rPr sz="1000">
+                <a:solidFill>
+                  <a:srgbClr val="323232"/>
+                </a:solidFill>
+                <a:latin typeface="Calibri"/>
+              </a:rPr>
+              <a:t> (pp. 1–6). IEEE.</a:t>
             </a:r>
           </a:p>
           <a:p>
             <a:pPr>
+              <a:lnSpc>
+                <a:spcPct val="110000"/>
+              </a:lnSpc>
               <a:spcAft>
                 <a:spcPts val="400"/>
               </a:spcAft>
@@ -7231,15 +8064,63 @@
             <a:r>
               <a:rPr sz="1000">
                 <a:solidFill>
+                  <a:srgbClr val="102C57"/>
+                </a:solidFill>
+                <a:latin typeface="Calibri"/>
+              </a:rPr>
+              <a:t>[7] </a:t>
+            </a:r>
+            <a:r>
+              <a:rPr sz="1000">
+                <a:solidFill>
                   <a:srgbClr val="323232"/>
                 </a:solidFill>
                 <a:latin typeface="Calibri"/>
               </a:rPr>
-              <a:t>[7] V. Srilakshmi, S. Arukonda, and V. L. Chetana, "A Transformer-Based Framework for Online Recruitment Fraud Detection," *Procedia CS*, vol. 283, pp. 1145-1153, 2026.</a:t>
+              <a:t>Srilakshmi, V., Arukonda, S., &amp; Chetana, V. L. (2026). A transformer-based framework for online recruitment fraud detection using BERT, RoBERTa, SMOBD, and 2D CNN. </a:t>
+            </a:r>
+            <a:r>
+              <a:rPr sz="1000">
+                <a:solidFill>
+                  <a:srgbClr val="323232"/>
+                </a:solidFill>
+                <a:latin typeface="Calibri"/>
+              </a:rPr>
+              <a:t>Procedia Computer Science</a:t>
+            </a:r>
+            <a:r>
+              <a:rPr sz="1000">
+                <a:solidFill>
+                  <a:srgbClr val="323232"/>
+                </a:solidFill>
+                <a:latin typeface="Calibri"/>
+              </a:rPr>
+              <a:t>, </a:t>
+            </a:r>
+            <a:r>
+              <a:rPr sz="1000">
+                <a:solidFill>
+                  <a:srgbClr val="323232"/>
+                </a:solidFill>
+                <a:latin typeface="Calibri"/>
+              </a:rPr>
+              <a:t>283</a:t>
+            </a:r>
+            <a:r>
+              <a:rPr sz="1000">
+                <a:solidFill>
+                  <a:srgbClr val="323232"/>
+                </a:solidFill>
+                <a:latin typeface="Calibri"/>
+              </a:rPr>
+              <a:t>, 1145–1153.</a:t>
             </a:r>
           </a:p>
           <a:p>
             <a:pPr>
+              <a:lnSpc>
+                <a:spcPct val="110000"/>
+              </a:lnSpc>
               <a:spcAft>
                 <a:spcPts val="400"/>
               </a:spcAft>
@@ -7247,19 +8128,21 @@
             <a:r>
               <a:rPr sz="1000">
                 <a:solidFill>
+                  <a:srgbClr val="102C57"/>
+                </a:solidFill>
+                <a:latin typeface="Calibri"/>
+              </a:rPr>
+              <a:t>[8] </a:t>
+            </a:r>
+            <a:r>
+              <a:rPr sz="1000">
+                <a:solidFill>
                   <a:srgbClr val="323232"/>
                 </a:solidFill>
                 <a:latin typeface="Calibri"/>
               </a:rPr>
-              <a:t>[8] S. Habib, A. Farooq, and S. N. Malik, "Fake Job Vacancy Detection Using Ensemble Voting Classifier," *IEEE DASA*, 2021.</a:t>
-            </a:r>
-          </a:p>
-          <a:p>
-            <a:pPr>
-              <a:spcAft>
-                <a:spcPts val="400"/>
-              </a:spcAft>
-            </a:pPr>
+              <a:t>Varshitha, G., Sowmya, K., Sheshma, K., Sowmya, K., &amp; Manikandan, R. A. (2026). Online recruitment fraud detection using deep learning approaches. </a:t>
+            </a:r>
             <a:r>
               <a:rPr sz="1000">
                 <a:solidFill>
@@ -7267,7 +8150,34 @@
                 </a:solidFill>
                 <a:latin typeface="Calibri"/>
               </a:rPr>
-              <a:t>[9] S. Alghamdi and G. Alharby, "Online Recruitment Fraud (ORF) Detection Using Gated Recurrent Unit," *IEEE Access*, vol. 7, pp. 13245-13253, 2019.</a:t>
+              <a:t>International Journal for Multidisciplinary Research (IJFMR)</a:t>
+            </a:r>
+            <a:r>
+              <a:rPr sz="1000">
+                <a:solidFill>
+                  <a:srgbClr val="323232"/>
+                </a:solidFill>
+                <a:latin typeface="Calibri"/>
+              </a:rPr>
+              <a:t>, </a:t>
+            </a:r>
+            <a:r>
+              <a:rPr sz="1000">
+                <a:solidFill>
+                  <a:srgbClr val="323232"/>
+                </a:solidFill>
+                <a:latin typeface="Calibri"/>
+              </a:rPr>
+              <a:t>8</a:t>
+            </a:r>
+            <a:r>
+              <a:rPr sz="1000">
+                <a:solidFill>
+                  <a:srgbClr val="323232"/>
+                </a:solidFill>
+                <a:latin typeface="Calibri"/>
+              </a:rPr>
+              <a:t>(2), 1–9.</a:t>
             </a:r>
           </a:p>
         </p:txBody>
@@ -7502,7 +8412,7 @@
                 </a:solidFill>
                 <a:latin typeface="Calibri"/>
               </a:rPr>
-              <a:t>11</a:t>
+              <a:t>12</a:t>
             </a:r>
           </a:p>
         </p:txBody>

</xml_diff>